<commit_message>
Lessons: fix layer classification in sd-02-018 and scope the stage claim in sd-02-022
Co-Authored-By: Claude Opus 5.5 <noreply@anthropic.com>
Claude-Session: https://claude.ai/code/session_01McBLtMnJbTnB94NeVs8a2V
</commit_message>
<xml_diff>
--- a/system-design-101/vi/lessons/sd-02-018/slides/sd-02-018.pptx
+++ b/system-design-101/vi/lessons/sd-02-018/slides/sd-02-018.pptx
@@ -2672,7 +2672,7 @@
               <a:buNone/>
             </a:pPr>
             <a:r>
-              <a:rPr lang="en-US" sz="3150" dirty="0" spc="-3" kern="0">
+              <a:rPr lang="en-US" sz="3150" dirty="0" spc="0" kern="0">
                 <a:solidFill>
                   <a:srgbClr val="FFB454"/>
                 </a:solidFill>
@@ -2680,7 +2680,7 @@
                 <a:ea typeface="Bricolage Grotesque ExtraBold" pitchFamily="34" charset="-122"/>
                 <a:cs typeface="Bricolage Grotesque ExtraBold" pitchFamily="34" charset="-120"/>
               </a:rPr>
-              <a:t>Hai</a:t>
+              <a:t>Ba</a:t>
             </a:r>
             <a:r>
               <a:rPr lang="en-US" sz="3150" dirty="0" spc="-21" kern="0">
@@ -8918,7 +8918,7 @@
               <a:buNone/>
             </a:pPr>
             <a:r>
-              <a:rPr lang="en-US" sz="6900" dirty="0" spc="-2" kern="0">
+              <a:rPr lang="en-US" sz="6900" dirty="0" spc="4" kern="0">
                 <a:solidFill>
                   <a:srgbClr val="14161C"/>
                 </a:solidFill>
@@ -8926,10 +8926,10 @@
                 <a:ea typeface="Bricolage Grotesque ExtraBold" pitchFamily="34" charset="-122"/>
                 <a:cs typeface="Bricolage Grotesque ExtraBold" pitchFamily="34" charset="-120"/>
               </a:rPr>
-              <a:t>Hai</a:t>
-            </a:r>
-            <a:r>
-              <a:rPr lang="en-US" sz="6900" dirty="0" spc="-43" kern="0">
+              <a:t>Thêm</a:t>
+            </a:r>
+            <a:r>
+              <a:rPr lang="en-US" sz="6900" dirty="0" spc="2" kern="0">
                 <a:solidFill>
                   <a:srgbClr val="14161C"/>
                 </a:solidFill>
@@ -8937,10 +8937,10 @@
                 <a:ea typeface="Bricolage Grotesque ExtraBold" pitchFamily="34" charset="-122"/>
                 <a:cs typeface="Bricolage Grotesque ExtraBold" pitchFamily="34" charset="-120"/>
               </a:rPr>
-              <a:t> lớp</a:t>
-            </a:r>
-            <a:r>
-              <a:rPr lang="en-US" sz="6900" dirty="0" spc="0" kern="0">
+              <a:t> hai</a:t>
+            </a:r>
+            <a:r>
+              <a:rPr lang="en-US" sz="6900" dirty="0" spc="-43" kern="0">
                 <a:solidFill>
                   <a:srgbClr val="14161C"/>
                 </a:solidFill>
@@ -8948,10 +8948,10 @@
                 <a:ea typeface="Bricolage Grotesque ExtraBold" pitchFamily="34" charset="-122"/>
                 <a:cs typeface="Bricolage Grotesque ExtraBold" pitchFamily="34" charset="-120"/>
               </a:rPr>
-              <a:t> không</a:t>
-            </a:r>
-            <a:r>
-              <a:rPr lang="en-US" sz="6900" dirty="0" spc="3" kern="0">
+              <a:t> lớp</a:t>
+            </a:r>
+            <a:r>
+              <a:rPr lang="en-US" sz="6900" dirty="0" spc="18" kern="0">
                 <a:solidFill>
                   <a:srgbClr val="14161C"/>
                 </a:solidFill>
@@ -8959,10 +8959,10 @@
                 <a:ea typeface="Bricolage Grotesque ExtraBold" pitchFamily="34" charset="-122"/>
                 <a:cs typeface="Bricolage Grotesque ExtraBold" pitchFamily="34" charset="-120"/>
               </a:rPr>
-              <a:t> phục</a:t>
-            </a:r>
-            <a:r>
-              <a:rPr lang="en-US" sz="6900" dirty="0" spc="1" kern="0">
+              <a:t> đứng</a:t>
+            </a:r>
+            <a:r>
+              <a:rPr lang="en-US" sz="6900" dirty="0" spc="-33" kern="0">
                 <a:solidFill>
                   <a:srgbClr val="14161C"/>
                 </a:solidFill>
@@ -8970,29 +8970,7 @@
                 <a:ea typeface="Bricolage Grotesque ExtraBold" pitchFamily="34" charset="-122"/>
                 <a:cs typeface="Bricolage Grotesque ExtraBold" pitchFamily="34" charset="-120"/>
               </a:rPr>
-              <a:t> vụ</a:t>
-            </a:r>
-            <a:r>
-              <a:rPr lang="en-US" sz="6900" dirty="0" spc="0" kern="0">
-                <a:solidFill>
-                  <a:srgbClr val="14161C"/>
-                </a:solidFill>
-                <a:latin typeface="Bricolage Grotesque ExtraBold" pitchFamily="34" charset="0"/>
-                <a:ea typeface="Bricolage Grotesque ExtraBold" pitchFamily="34" charset="-122"/>
-                <a:cs typeface="Bricolage Grotesque ExtraBold" pitchFamily="34" charset="-120"/>
-              </a:rPr>
-              <a:t> cú</a:t>
-            </a:r>
-            <a:r>
-              <a:rPr lang="en-US" sz="6900" dirty="0" spc="-5" kern="0">
-                <a:solidFill>
-                  <a:srgbClr val="14161C"/>
-                </a:solidFill>
-                <a:latin typeface="Bricolage Grotesque ExtraBold" pitchFamily="34" charset="0"/>
-                <a:ea typeface="Bricolage Grotesque ExtraBold" pitchFamily="34" charset="-122"/>
-                <a:cs typeface="Bricolage Grotesque ExtraBold" pitchFamily="34" charset="-120"/>
-              </a:rPr>
-              <a:t> bấm</a:t>
+              <a:t> ngoài</a:t>
             </a:r>
             <a:endParaRPr lang="en-US" sz="6900" dirty="0"/>
           </a:p>
@@ -9483,7 +9461,7 @@
               <a:buNone/>
             </a:pPr>
             <a:r>
-              <a:rPr lang="en-US" sz="2250" dirty="0" spc="-8" kern="0">
+              <a:rPr lang="en-US" sz="2250" dirty="0" spc="-1" kern="0">
                 <a:solidFill>
                   <a:srgbClr val="14161C"/>
                 </a:solidFill>
@@ -9491,7 +9469,7 @@
                 <a:ea typeface="Be Vietnam Pro" pitchFamily="34" charset="-122"/>
                 <a:cs typeface="Be Vietnam Pro" pitchFamily="34" charset="-120"/>
               </a:rPr>
-              <a:t>Một</a:t>
+              <a:t>Cùng</a:t>
             </a:r>
             <a:r>
               <a:rPr lang="en-US" sz="2250" dirty="0" spc="3" kern="0">
@@ -9505,6 +9483,50 @@
               <a:t> lớp</a:t>
             </a:r>
             <a:r>
+              <a:rPr lang="en-US" sz="2250" dirty="0" spc="-12" kern="0">
+                <a:solidFill>
+                  <a:srgbClr val="14161C"/>
+                </a:solidFill>
+                <a:latin typeface="Be Vietnam Pro" pitchFamily="34" charset="0"/>
+                <a:ea typeface="Be Vietnam Pro" pitchFamily="34" charset="-122"/>
+                <a:cs typeface="Be Vietnam Pro" pitchFamily="34" charset="-120"/>
+              </a:rPr>
+              <a:t> truyền</a:t>
+            </a:r>
+            <a:r>
+              <a:rPr lang="en-US" sz="2250" dirty="0" spc="-1" kern="0">
+                <a:solidFill>
+                  <a:srgbClr val="14161C"/>
+                </a:solidFill>
+                <a:latin typeface="Be Vietnam Pro" pitchFamily="34" charset="0"/>
+                <a:ea typeface="Be Vietnam Pro" pitchFamily="34" charset="-122"/>
+                <a:cs typeface="Be Vietnam Pro" pitchFamily="34" charset="-120"/>
+              </a:rPr>
+              <a:t> tin,</a:t>
+            </a:r>
+            <a:r>
+              <a:rPr lang="en-US" sz="2250" dirty="0" spc="-2" kern="0">
+                <a:solidFill>
+                  <a:srgbClr val="14161C"/>
+                </a:solidFill>
+                <a:latin typeface="Be Vietnam Pro" pitchFamily="34" charset="0"/>
+                <a:ea typeface="Be Vietnam Pro" pitchFamily="34" charset="-122"/>
+                <a:cs typeface="Be Vietnam Pro" pitchFamily="34" charset="-120"/>
+              </a:rPr>
+              <a:t> ba</a:t>
+            </a:r>
+            <a:r>
+              <a:rPr lang="en-US" sz="2250" dirty="0" spc="3" kern="0">
+                <a:solidFill>
+                  <a:srgbClr val="14161C"/>
+                </a:solidFill>
+                <a:latin typeface="Be Vietnam Pro" pitchFamily="34" charset="0"/>
+                <a:ea typeface="Be Vietnam Pro" pitchFamily="34" charset="-122"/>
+                <a:cs typeface="Be Vietnam Pro" pitchFamily="34" charset="-120"/>
+              </a:rPr>
+              <a:t> lớp</a:t>
+            </a:r>
+            <a:r>
               <a:rPr lang="en-US" sz="2250" dirty="0" spc="1" kern="0">
                 <a:solidFill>
                   <a:srgbClr val="14161C"/>
@@ -9513,10 +9535,10 @@
                 <a:ea typeface="Be Vietnam Pro" pitchFamily="34" charset="-122"/>
                 <a:cs typeface="Be Vietnam Pro" pitchFamily="34" charset="-120"/>
               </a:rPr>
-              <a:t> phân tích</a:t>
-            </a:r>
-            <a:r>
-              <a:rPr lang="en-US" sz="2250" dirty="0" spc="5" kern="0">
+              <a:t> không</a:t>
+            </a:r>
+            <a:r>
+              <a:rPr lang="en-US" sz="2250" dirty="0" spc="4" kern="0">
                 <a:solidFill>
                   <a:srgbClr val="14161C"/>
                 </a:solidFill>
@@ -9524,7 +9546,29 @@
                 <a:ea typeface="Be Vietnam Pro" pitchFamily="34" charset="-122"/>
                 <a:cs typeface="Be Vietnam Pro" pitchFamily="34" charset="-120"/>
               </a:rPr>
-              <a:t> dữ</a:t>
+              <a:t> phục</a:t>
+            </a:r>
+            <a:r>
+              <a:rPr lang="en-US" sz="2250" dirty="0" spc="2" kern="0">
+                <a:solidFill>
+                  <a:srgbClr val="14161C"/>
+                </a:solidFill>
+                <a:latin typeface="Be Vietnam Pro" pitchFamily="34" charset="0"/>
+                <a:ea typeface="Be Vietnam Pro" pitchFamily="34" charset="-122"/>
+                <a:cs typeface="Be Vietnam Pro" pitchFamily="34" charset="-120"/>
+              </a:rPr>
+              <a:t> vụ</a:t>
+            </a:r>
+            <a:r>
+              <a:rPr lang="en-US" sz="2250" dirty="0" spc="4" kern="0">
+                <a:solidFill>
+                  <a:srgbClr val="14161C"/>
+                </a:solidFill>
+                <a:latin typeface="Be Vietnam Pro" pitchFamily="34" charset="0"/>
+                <a:ea typeface="Be Vietnam Pro" pitchFamily="34" charset="-122"/>
+                <a:cs typeface="Be Vietnam Pro" pitchFamily="34" charset="-120"/>
+              </a:rPr>
+              <a:t> cú</a:t>
             </a:r>
             <a:r>
               <a:rPr lang="en-US" sz="2250" dirty="0" spc="-2" kern="0">
@@ -9535,10 +9579,10 @@
                 <a:ea typeface="Be Vietnam Pro" pitchFamily="34" charset="-122"/>
                 <a:cs typeface="Be Vietnam Pro" pitchFamily="34" charset="-120"/>
               </a:rPr>
-              <a:t> liệu</a:t>
-            </a:r>
-            <a:r>
-              <a:rPr lang="en-US" sz="2250" dirty="0" spc="16" kern="0">
+              <a:t> bấm</a:t>
+            </a:r>
+            <a:r>
+              <a:rPr lang="en-US" sz="2250" dirty="0" spc="-14" kern="0">
                 <a:solidFill>
                   <a:srgbClr val="14161C"/>
                 </a:solidFill>
@@ -9546,95 +9590,7 @@
                 <a:ea typeface="Be Vietnam Pro" pitchFamily="34" charset="-122"/>
                 <a:cs typeface="Be Vietnam Pro" pitchFamily="34" charset="-120"/>
               </a:rPr>
-              <a:t> đã</a:t>
-            </a:r>
-            <a:r>
-              <a:rPr lang="en-US" sz="2250" dirty="0" spc="1" kern="0">
-                <a:solidFill>
-                  <a:srgbClr val="14161C"/>
-                </a:solidFill>
-                <a:latin typeface="Be Vietnam Pro" pitchFamily="34" charset="0"/>
-                <a:ea typeface="Be Vietnam Pro" pitchFamily="34" charset="-122"/>
-                <a:cs typeface="Be Vietnam Pro" pitchFamily="34" charset="-120"/>
-              </a:rPr>
-              <a:t> sinh</a:t>
-            </a:r>
-            <a:r>
-              <a:rPr lang="en-US" sz="2250" dirty="0" spc="-25" kern="0">
-                <a:solidFill>
-                  <a:srgbClr val="14161C"/>
-                </a:solidFill>
-                <a:latin typeface="Be Vietnam Pro" pitchFamily="34" charset="0"/>
-                <a:ea typeface="Be Vietnam Pro" pitchFamily="34" charset="-122"/>
-                <a:cs typeface="Be Vietnam Pro" pitchFamily="34" charset="-120"/>
-              </a:rPr>
-              <a:t> ra;</a:t>
-            </a:r>
-            <a:r>
-              <a:rPr lang="en-US" sz="2250" dirty="0" spc="3" kern="0">
-                <a:solidFill>
-                  <a:srgbClr val="14161C"/>
-                </a:solidFill>
-                <a:latin typeface="Be Vietnam Pro" pitchFamily="34" charset="0"/>
-                <a:ea typeface="Be Vietnam Pro" pitchFamily="34" charset="-122"/>
-                <a:cs typeface="Be Vietnam Pro" pitchFamily="34" charset="-120"/>
-              </a:rPr>
-              <a:t> lớp</a:t>
-            </a:r>
-            <a:r>
-              <a:rPr lang="en-US" sz="2250" dirty="0" spc="-2" kern="0">
-                <a:solidFill>
-                  <a:srgbClr val="14161C"/>
-                </a:solidFill>
-                <a:latin typeface="Be Vietnam Pro" pitchFamily="34" charset="0"/>
-                <a:ea typeface="Be Vietnam Pro" pitchFamily="34" charset="-122"/>
-                <a:cs typeface="Be Vietnam Pro" pitchFamily="34" charset="-120"/>
-              </a:rPr>
-              <a:t> kia</a:t>
-            </a:r>
-            <a:r>
-              <a:rPr lang="en-US" sz="2250" dirty="0" spc="8" kern="0">
-                <a:solidFill>
-                  <a:srgbClr val="14161C"/>
-                </a:solidFill>
-                <a:latin typeface="Be Vietnam Pro" pitchFamily="34" charset="0"/>
-                <a:ea typeface="Be Vietnam Pro" pitchFamily="34" charset="-122"/>
-                <a:cs typeface="Be Vietnam Pro" pitchFamily="34" charset="-120"/>
-              </a:rPr>
-              <a:t> đưa</a:t>
-            </a:r>
-            <a:r>
-              <a:rPr lang="en-US" sz="2250" dirty="0" spc="-2" kern="0">
-                <a:solidFill>
-                  <a:srgbClr val="14161C"/>
-                </a:solidFill>
-                <a:latin typeface="Be Vietnam Pro" pitchFamily="34" charset="0"/>
-                <a:ea typeface="Be Vietnam Pro" pitchFamily="34" charset="-122"/>
-                <a:cs typeface="Be Vietnam Pro" pitchFamily="34" charset="-120"/>
-              </a:rPr>
-              <a:t> mã</a:t>
-            </a:r>
-            <a:r>
-              <a:rPr lang="en-US" sz="2250" dirty="0" spc="0" kern="0">
-                <a:solidFill>
-                  <a:srgbClr val="14161C"/>
-                </a:solidFill>
-                <a:latin typeface="Be Vietnam Pro" pitchFamily="34" charset="0"/>
-                <a:ea typeface="Be Vietnam Pro" pitchFamily="34" charset="-122"/>
-                <a:cs typeface="Be Vietnam Pro" pitchFamily="34" charset="-120"/>
-              </a:rPr>
-              <a:t> mới</a:t>
-            </a:r>
-            <a:r>
-              <a:rPr lang="en-US" sz="2250" dirty="0" spc="-10" kern="0">
-                <a:solidFill>
-                  <a:srgbClr val="14161C"/>
-                </a:solidFill>
-                <a:latin typeface="Be Vietnam Pro" pitchFamily="34" charset="0"/>
-                <a:ea typeface="Be Vietnam Pro" pitchFamily="34" charset="-122"/>
-                <a:cs typeface="Be Vietnam Pro" pitchFamily="34" charset="-120"/>
-              </a:rPr>
-              <a:t> vào.</a:t>
+              <a:t> xem.</a:t>
             </a:r>
             <a:endParaRPr lang="en-US" sz="2250" dirty="0"/>
           </a:p>
@@ -11993,10 +11949,10 @@
                 <a:ea typeface="Be Vietnam Pro" pitchFamily="34" charset="-122"/>
                 <a:cs typeface="Be Vietnam Pro" pitchFamily="34" charset="-120"/>
               </a:rPr>
-              <a:t>Hai</a:t>
-            </a:r>
-            <a:r>
-              <a:rPr lang="en-US" sz="2250" b="1" dirty="0" spc="-1" kern="0">
+              <a:t>Ba lớp</a:t>
+            </a:r>
+            <a:r>
+              <a:rPr lang="en-US" sz="2250" b="1" dirty="0" spc="3" kern="0">
                 <a:solidFill>
                   <a:srgbClr val="0F766E"/>
                 </a:solidFill>
@@ -12004,10 +11960,10 @@
                 <a:ea typeface="Be Vietnam Pro" pitchFamily="34" charset="-122"/>
                 <a:cs typeface="Be Vietnam Pro" pitchFamily="34" charset="-120"/>
               </a:rPr>
-              <a:t> lớp</a:t>
-            </a:r>
-            <a:r>
-              <a:rPr lang="en-US" sz="2250" b="1" dirty="0" spc="3" kern="0">
+              <a:t> kia</a:t>
+            </a:r>
+            <a:r>
+              <a:rPr lang="en-US" sz="2250" b="1" dirty="0" spc="20" kern="0">
                 <a:solidFill>
                   <a:srgbClr val="0F766E"/>
                 </a:solidFill>
@@ -12015,21 +11971,10 @@
                 <a:ea typeface="Be Vietnam Pro" pitchFamily="34" charset="-122"/>
                 <a:cs typeface="Be Vietnam Pro" pitchFamily="34" charset="-120"/>
               </a:rPr>
-              <a:t> kia</a:t>
-            </a:r>
-            <a:r>
-              <a:rPr lang="en-US" sz="2250" b="1" dirty="0" spc="21" kern="0">
-                <a:solidFill>
-                  <a:srgbClr val="0F766E"/>
-                </a:solidFill>
-                <a:latin typeface="Be Vietnam Pro" pitchFamily="34" charset="0"/>
-                <a:ea typeface="Be Vietnam Pro" pitchFamily="34" charset="-122"/>
-                <a:cs typeface="Be Vietnam Pro" pitchFamily="34" charset="-120"/>
-              </a:rPr>
               <a:t> đứng</a:t>
             </a:r>
             <a:r>
-              <a:rPr lang="en-US" sz="2250" b="1" dirty="0" spc="-5" kern="0">
+              <a:rPr lang="en-US" sz="2250" b="1" dirty="0" spc="-4" kern="0">
                 <a:solidFill>
                   <a:srgbClr val="0F766E"/>
                 </a:solidFill>

</xml_diff>

<commit_message>
sd-02-018: glossary entries for the EV and DB in EVCache and CockroachDB
Co-Authored-By: Claude Opus 5.5 <noreply@anthropic.com>
Claude-Session: https://claude.ai/code/session_01McBLtMnJbTnB94NeVs8a2V
</commit_message>
<xml_diff>
--- a/system-design-101/vi/lessons/sd-02-018/slides/sd-02-018.pptx
+++ b/system-design-101/vi/lessons/sd-02-018/slides/sd-02-018.pptx
@@ -2968,7 +2968,7 @@
           </p:nvPr>
         </p:nvGraphicFramePr>
         <p:xfrm>
-          <a:off x="914400" y="2476500"/>
+          <a:off x="914400" y="2381250"/>
           <a:ext cx="13716000" cy="914400"/>
         </p:xfrm>
         <a:graphic>
@@ -2980,7 +2980,7 @@
                 <a:gridCol w="6254496"/>
                 <a:gridCol w="7900416"/>
               </a:tblGrid>
-              <a:tr h="990600">
+              <a:tr h="800100">
                 <a:tc>
                   <a:txBody>
                     <a:bodyPr/>
@@ -3179,7 +3179,7 @@
                   </a:tcPr>
                 </a:tc>
               </a:tr>
-              <a:tr h="990600">
+              <a:tr h="800100">
                 <a:tc>
                   <a:txBody>
                     <a:bodyPr/>
@@ -3396,7 +3396,7 @@
                   </a:tcPr>
                 </a:tc>
               </a:tr>
-              <a:tr h="990600">
+              <a:tr h="800100">
                 <a:tc>
                   <a:txBody>
                     <a:bodyPr/>
@@ -3613,7 +3613,7 @@
                   </a:tcPr>
                 </a:tc>
               </a:tr>
-              <a:tr h="990600">
+              <a:tr h="800100">
                 <a:tc>
                   <a:txBody>
                     <a:bodyPr/>
@@ -3852,6 +3852,473 @@
                   </a:tcPr>
                 </a:tc>
               </a:tr>
+              <a:tr h="800100">
+                <a:tc>
+                  <a:txBody>
+                    <a:bodyPr/>
+                    <a:lstStyle/>
+                    <a:p>
+                      <a:pPr algn="l" indent="0" marL="0">
+                        <a:lnSpc>
+                          <a:spcPts val="2700"/>
+                        </a:lnSpc>
+                        <a:buNone/>
+                      </a:pPr>
+                      <a:r>
+                        <a:rPr lang="en-US" sz="2250" dirty="0" spc="-2" kern="0">
+                          <a:solidFill>
+                            <a:srgbClr val="FF6A4D"/>
+                          </a:solidFill>
+                          <a:latin typeface="Be Vietnam Pro" pitchFamily="34" charset="0"/>
+                          <a:ea typeface="Be Vietnam Pro" pitchFamily="34" charset="-122"/>
+                          <a:cs typeface="Be Vietnam Pro" pitchFamily="34" charset="-120"/>
+                        </a:rPr>
+                        <a:t>EV</a:t>
+                      </a:r>
+                      <a:endParaRPr lang="en-US" sz="1200" dirty="0"/>
+                    </a:p>
+                  </a:txBody>
+                  <a:tcPr marL="76200" marR="76200" marT="76200" marB="76200">
+                    <a:lnL w="9525" cap="flat" cmpd="sng" algn="ctr">
+                      <a:solidFill>
+                        <a:srgbClr val="2D3140"/>
+                      </a:solidFill>
+                      <a:prstDash val="solid"/>
+                      <a:round/>
+                      <a:headEnd type="none" w="med" len="med"/>
+                      <a:tailEnd type="none" w="med" len="med"/>
+                    </a:lnL>
+                    <a:lnR w="0" cap="flat" cmpd="sng" algn="ctr">
+                      <a:noFill/>
+                    </a:lnR>
+                    <a:lnT w="9525" cap="flat" cmpd="sng" algn="ctr">
+                      <a:solidFill>
+                        <a:srgbClr val="2D3140"/>
+                      </a:solidFill>
+                      <a:prstDash val="solid"/>
+                      <a:round/>
+                      <a:headEnd type="none" w="med" len="med"/>
+                      <a:tailEnd type="none" w="med" len="med"/>
+                    </a:lnT>
+                    <a:lnB w="0" cap="flat" cmpd="sng" algn="ctr">
+                      <a:noFill/>
+                    </a:lnB>
+                    <a:solidFill>
+                      <a:srgbClr val="14161C"/>
+                    </a:solidFill>
+                  </a:tcPr>
+                </a:tc>
+                <a:tc>
+                  <a:txBody>
+                    <a:bodyPr/>
+                    <a:lstStyle/>
+                    <a:p>
+                      <a:pPr algn="l" indent="0" marL="0">
+                        <a:lnSpc>
+                          <a:spcPts val="2700"/>
+                        </a:lnSpc>
+                        <a:buNone/>
+                      </a:pPr>
+                      <a:r>
+                        <a:rPr lang="en-US" sz="2250" dirty="0" spc="-12" kern="0">
+                          <a:solidFill>
+                            <a:srgbClr val="E4E1D8"/>
+                          </a:solidFill>
+                          <a:latin typeface="Be Vietnam Pro" pitchFamily="34" charset="0"/>
+                          <a:ea typeface="Be Vietnam Pro" pitchFamily="34" charset="-122"/>
+                          <a:cs typeface="Be Vietnam Pro" pitchFamily="34" charset="-120"/>
+                        </a:rPr>
+                        <a:t>Ephemeral</a:t>
+                      </a:r>
+                      <a:r>
+                        <a:rPr lang="en-US" sz="2250" dirty="0" spc="-18" kern="0">
+                          <a:solidFill>
+                            <a:srgbClr val="E4E1D8"/>
+                          </a:solidFill>
+                          <a:latin typeface="Be Vietnam Pro" pitchFamily="34" charset="0"/>
+                          <a:ea typeface="Be Vietnam Pro" pitchFamily="34" charset="-122"/>
+                          <a:cs typeface="Be Vietnam Pro" pitchFamily="34" charset="-120"/>
+                        </a:rPr>
+                        <a:t> Volatile</a:t>
+                      </a:r>
+                      <a:endParaRPr lang="en-US" sz="1200" dirty="0"/>
+                    </a:p>
+                  </a:txBody>
+                  <a:tcPr marL="76200" marR="76200" marT="76200" marB="76200">
+                    <a:lnL w="9525" cap="flat" cmpd="sng" algn="ctr">
+                      <a:solidFill>
+                        <a:srgbClr val="2D3140"/>
+                      </a:solidFill>
+                      <a:prstDash val="solid"/>
+                      <a:round/>
+                      <a:headEnd type="none" w="med" len="med"/>
+                      <a:tailEnd type="none" w="med" len="med"/>
+                    </a:lnL>
+                    <a:lnR w="0" cap="flat" cmpd="sng" algn="ctr">
+                      <a:noFill/>
+                    </a:lnR>
+                    <a:lnT w="9525" cap="flat" cmpd="sng" algn="ctr">
+                      <a:solidFill>
+                        <a:srgbClr val="2D3140"/>
+                      </a:solidFill>
+                      <a:prstDash val="solid"/>
+                      <a:round/>
+                      <a:headEnd type="none" w="med" len="med"/>
+                      <a:tailEnd type="none" w="med" len="med"/>
+                    </a:lnT>
+                    <a:lnB w="0" cap="flat" cmpd="sng" algn="ctr">
+                      <a:noFill/>
+                    </a:lnB>
+                    <a:solidFill>
+                      <a:srgbClr val="14161C"/>
+                    </a:solidFill>
+                  </a:tcPr>
+                </a:tc>
+                <a:tc>
+                  <a:txBody>
+                    <a:bodyPr/>
+                    <a:lstStyle/>
+                    <a:p>
+                      <a:pPr algn="l" indent="0" marL="0">
+                        <a:lnSpc>
+                          <a:spcPts val="2700"/>
+                        </a:lnSpc>
+                        <a:buNone/>
+                      </a:pPr>
+                      <a:r>
+                        <a:rPr lang="en-US" sz="2250" dirty="0" spc="-18" kern="0">
+                          <a:solidFill>
+                            <a:srgbClr val="E4E1D8"/>
+                          </a:solidFill>
+                          <a:latin typeface="Be Vietnam Pro" pitchFamily="34" charset="0"/>
+                          <a:ea typeface="Be Vietnam Pro" pitchFamily="34" charset="-122"/>
+                          <a:cs typeface="Be Vietnam Pro" pitchFamily="34" charset="-120"/>
+                        </a:rPr>
+                        <a:t>tạm</a:t>
+                      </a:r>
+                      <a:r>
+                        <a:rPr lang="en-US" sz="2250" dirty="0" spc="0" kern="0">
+                          <a:solidFill>
+                            <a:srgbClr val="E4E1D8"/>
+                          </a:solidFill>
+                          <a:latin typeface="Be Vietnam Pro" pitchFamily="34" charset="0"/>
+                          <a:ea typeface="Be Vietnam Pro" pitchFamily="34" charset="-122"/>
+                          <a:cs typeface="Be Vietnam Pro" pitchFamily="34" charset="-120"/>
+                        </a:rPr>
+                        <a:t> thời,</a:t>
+                      </a:r>
+                      <a:r>
+                        <a:rPr lang="en-US" sz="2250" dirty="0" spc="1" kern="0">
+                          <a:solidFill>
+                            <a:srgbClr val="E4E1D8"/>
+                          </a:solidFill>
+                          <a:latin typeface="Be Vietnam Pro" pitchFamily="34" charset="0"/>
+                          <a:ea typeface="Be Vietnam Pro" pitchFamily="34" charset="-122"/>
+                          <a:cs typeface="Be Vietnam Pro" pitchFamily="34" charset="-120"/>
+                        </a:rPr>
+                        <a:t> dễ</a:t>
+                      </a:r>
+                      <a:r>
+                        <a:rPr lang="en-US" sz="2250" dirty="0" spc="-11" kern="0">
+                          <a:solidFill>
+                            <a:srgbClr val="E4E1D8"/>
+                          </a:solidFill>
+                          <a:latin typeface="Be Vietnam Pro" pitchFamily="34" charset="0"/>
+                          <a:ea typeface="Be Vietnam Pro" pitchFamily="34" charset="-122"/>
+                          <a:cs typeface="Be Vietnam Pro" pitchFamily="34" charset="-120"/>
+                        </a:rPr>
+                        <a:t> mất,</a:t>
+                      </a:r>
+                      <a:r>
+                        <a:rPr lang="en-US" sz="2250" dirty="0" spc="-16" kern="0">
+                          <a:solidFill>
+                            <a:srgbClr val="E4E1D8"/>
+                          </a:solidFill>
+                          <a:latin typeface="Be Vietnam Pro" pitchFamily="34" charset="0"/>
+                          <a:ea typeface="Be Vietnam Pro" pitchFamily="34" charset="-122"/>
+                          <a:cs typeface="Be Vietnam Pro" pitchFamily="34" charset="-120"/>
+                        </a:rPr>
+                        <a:t> trong</a:t>
+                      </a:r>
+                      <a:r>
+                        <a:rPr lang="en-US" sz="2250" dirty="0" spc="-7" kern="0">
+                          <a:solidFill>
+                            <a:srgbClr val="E4E1D8"/>
+                          </a:solidFill>
+                          <a:latin typeface="Be Vietnam Pro" pitchFamily="34" charset="0"/>
+                          <a:ea typeface="Be Vietnam Pro" pitchFamily="34" charset="-122"/>
+                          <a:cs typeface="Be Vietnam Pro" pitchFamily="34" charset="-120"/>
+                        </a:rPr>
+                        <a:t> EVCache</a:t>
+                      </a:r>
+                      <a:endParaRPr lang="en-US" sz="1200" dirty="0"/>
+                    </a:p>
+                  </a:txBody>
+                  <a:tcPr marL="76200" marR="76200" marT="76200" marB="76200">
+                    <a:lnL w="9525" cap="flat" cmpd="sng" algn="ctr">
+                      <a:solidFill>
+                        <a:srgbClr val="2D3140"/>
+                      </a:solidFill>
+                      <a:prstDash val="solid"/>
+                      <a:round/>
+                      <a:headEnd type="none" w="med" len="med"/>
+                      <a:tailEnd type="none" w="med" len="med"/>
+                    </a:lnL>
+                    <a:lnR w="9525" cap="flat" cmpd="sng" algn="ctr">
+                      <a:solidFill>
+                        <a:srgbClr val="2D3140"/>
+                      </a:solidFill>
+                      <a:prstDash val="solid"/>
+                      <a:round/>
+                      <a:headEnd type="none" w="med" len="med"/>
+                      <a:tailEnd type="none" w="med" len="med"/>
+                    </a:lnR>
+                    <a:lnT w="9525" cap="flat" cmpd="sng" algn="ctr">
+                      <a:solidFill>
+                        <a:srgbClr val="2D3140"/>
+                      </a:solidFill>
+                      <a:prstDash val="solid"/>
+                      <a:round/>
+                      <a:headEnd type="none" w="med" len="med"/>
+                      <a:tailEnd type="none" w="med" len="med"/>
+                    </a:lnT>
+                    <a:lnB w="0" cap="flat" cmpd="sng" algn="ctr">
+                      <a:noFill/>
+                    </a:lnB>
+                    <a:solidFill>
+                      <a:srgbClr val="14161C"/>
+                    </a:solidFill>
+                  </a:tcPr>
+                </a:tc>
+              </a:tr>
+              <a:tr h="800100">
+                <a:tc>
+                  <a:txBody>
+                    <a:bodyPr/>
+                    <a:lstStyle/>
+                    <a:p>
+                      <a:pPr algn="l" indent="0" marL="0">
+                        <a:lnSpc>
+                          <a:spcPts val="2700"/>
+                        </a:lnSpc>
+                        <a:buNone/>
+                      </a:pPr>
+                      <a:r>
+                        <a:rPr lang="en-US" sz="2250" dirty="0" spc="2" kern="0">
+                          <a:solidFill>
+                            <a:srgbClr val="FF6A4D"/>
+                          </a:solidFill>
+                          <a:latin typeface="Be Vietnam Pro" pitchFamily="34" charset="0"/>
+                          <a:ea typeface="Be Vietnam Pro" pitchFamily="34" charset="-122"/>
+                          <a:cs typeface="Be Vietnam Pro" pitchFamily="34" charset="-120"/>
+                        </a:rPr>
+                        <a:t>DB</a:t>
+                      </a:r>
+                      <a:endParaRPr lang="en-US" sz="1200" dirty="0"/>
+                    </a:p>
+                  </a:txBody>
+                  <a:tcPr marL="76200" marR="76200" marT="76200" marB="76200">
+                    <a:lnL w="9525" cap="flat" cmpd="sng" algn="ctr">
+                      <a:solidFill>
+                        <a:srgbClr val="2D3140"/>
+                      </a:solidFill>
+                      <a:prstDash val="solid"/>
+                      <a:round/>
+                      <a:headEnd type="none" w="med" len="med"/>
+                      <a:tailEnd type="none" w="med" len="med"/>
+                    </a:lnL>
+                    <a:lnR w="0" cap="flat" cmpd="sng" algn="ctr">
+                      <a:noFill/>
+                    </a:lnR>
+                    <a:lnT w="9525" cap="flat" cmpd="sng" algn="ctr">
+                      <a:solidFill>
+                        <a:srgbClr val="2D3140"/>
+                      </a:solidFill>
+                      <a:prstDash val="solid"/>
+                      <a:round/>
+                      <a:headEnd type="none" w="med" len="med"/>
+                      <a:tailEnd type="none" w="med" len="med"/>
+                    </a:lnT>
+                    <a:lnB w="0" cap="flat" cmpd="sng" algn="ctr">
+                      <a:noFill/>
+                    </a:lnB>
+                    <a:solidFill>
+                      <a:srgbClr val="1A1D25"/>
+                    </a:solidFill>
+                  </a:tcPr>
+                </a:tc>
+                <a:tc>
+                  <a:txBody>
+                    <a:bodyPr/>
+                    <a:lstStyle/>
+                    <a:p>
+                      <a:pPr algn="l" indent="0" marL="0">
+                        <a:lnSpc>
+                          <a:spcPts val="2700"/>
+                        </a:lnSpc>
+                        <a:buNone/>
+                      </a:pPr>
+                      <a:r>
+                        <a:rPr lang="en-US" sz="2250" dirty="0" spc="-15" kern="0">
+                          <a:solidFill>
+                            <a:srgbClr val="E4E1D8"/>
+                          </a:solidFill>
+                          <a:latin typeface="Be Vietnam Pro" pitchFamily="34" charset="0"/>
+                          <a:ea typeface="Be Vietnam Pro" pitchFamily="34" charset="-122"/>
+                          <a:cs typeface="Be Vietnam Pro" pitchFamily="34" charset="-120"/>
+                        </a:rPr>
+                        <a:t>DataBase</a:t>
+                      </a:r>
+                      <a:endParaRPr lang="en-US" sz="1200" dirty="0"/>
+                    </a:p>
+                  </a:txBody>
+                  <a:tcPr marL="76200" marR="76200" marT="76200" marB="76200">
+                    <a:lnL w="9525" cap="flat" cmpd="sng" algn="ctr">
+                      <a:solidFill>
+                        <a:srgbClr val="2D3140"/>
+                      </a:solidFill>
+                      <a:prstDash val="solid"/>
+                      <a:round/>
+                      <a:headEnd type="none" w="med" len="med"/>
+                      <a:tailEnd type="none" w="med" len="med"/>
+                    </a:lnL>
+                    <a:lnR w="0" cap="flat" cmpd="sng" algn="ctr">
+                      <a:noFill/>
+                    </a:lnR>
+                    <a:lnT w="9525" cap="flat" cmpd="sng" algn="ctr">
+                      <a:solidFill>
+                        <a:srgbClr val="2D3140"/>
+                      </a:solidFill>
+                      <a:prstDash val="solid"/>
+                      <a:round/>
+                      <a:headEnd type="none" w="med" len="med"/>
+                      <a:tailEnd type="none" w="med" len="med"/>
+                    </a:lnT>
+                    <a:lnB w="0" cap="flat" cmpd="sng" algn="ctr">
+                      <a:noFill/>
+                    </a:lnB>
+                    <a:solidFill>
+                      <a:srgbClr val="1A1D25"/>
+                    </a:solidFill>
+                  </a:tcPr>
+                </a:tc>
+                <a:tc>
+                  <a:txBody>
+                    <a:bodyPr/>
+                    <a:lstStyle/>
+                    <a:p>
+                      <a:pPr algn="l" indent="0" marL="0">
+                        <a:lnSpc>
+                          <a:spcPts val="2700"/>
+                        </a:lnSpc>
+                        <a:buNone/>
+                      </a:pPr>
+                      <a:r>
+                        <a:rPr lang="en-US" sz="2250" dirty="0" spc="-1" kern="0">
+                          <a:solidFill>
+                            <a:srgbClr val="E4E1D8"/>
+                          </a:solidFill>
+                          <a:latin typeface="Be Vietnam Pro" pitchFamily="34" charset="0"/>
+                          <a:ea typeface="Be Vietnam Pro" pitchFamily="34" charset="-122"/>
+                          <a:cs typeface="Be Vietnam Pro" pitchFamily="34" charset="-120"/>
+                        </a:rPr>
+                        <a:t>cơ</a:t>
+                      </a:r>
+                      <a:r>
+                        <a:rPr lang="en-US" sz="2250" dirty="0" spc="-2" kern="0">
+                          <a:solidFill>
+                            <a:srgbClr val="E4E1D8"/>
+                          </a:solidFill>
+                          <a:latin typeface="Be Vietnam Pro" pitchFamily="34" charset="0"/>
+                          <a:ea typeface="Be Vietnam Pro" pitchFamily="34" charset="-122"/>
+                          <a:cs typeface="Be Vietnam Pro" pitchFamily="34" charset="-120"/>
+                        </a:rPr>
+                        <a:t> sở</a:t>
+                      </a:r>
+                      <a:r>
+                        <a:rPr lang="en-US" sz="2250" dirty="0" spc="4" kern="0">
+                          <a:solidFill>
+                            <a:srgbClr val="E4E1D8"/>
+                          </a:solidFill>
+                          <a:latin typeface="Be Vietnam Pro" pitchFamily="34" charset="0"/>
+                          <a:ea typeface="Be Vietnam Pro" pitchFamily="34" charset="-122"/>
+                          <a:cs typeface="Be Vietnam Pro" pitchFamily="34" charset="-120"/>
+                        </a:rPr>
+                        <a:t> dữ</a:t>
+                      </a:r>
+                      <a:r>
+                        <a:rPr lang="en-US" sz="2250" dirty="0" spc="-2" kern="0">
+                          <a:solidFill>
+                            <a:srgbClr val="E4E1D8"/>
+                          </a:solidFill>
+                          <a:latin typeface="Be Vietnam Pro" pitchFamily="34" charset="0"/>
+                          <a:ea typeface="Be Vietnam Pro" pitchFamily="34" charset="-122"/>
+                          <a:cs typeface="Be Vietnam Pro" pitchFamily="34" charset="-120"/>
+                        </a:rPr>
+                        <a:t> liệu,</a:t>
+                      </a:r>
+                      <a:r>
+                        <a:rPr lang="en-US" sz="2250" dirty="0" spc="-16" kern="0">
+                          <a:solidFill>
+                            <a:srgbClr val="E4E1D8"/>
+                          </a:solidFill>
+                          <a:latin typeface="Be Vietnam Pro" pitchFamily="34" charset="0"/>
+                          <a:ea typeface="Be Vietnam Pro" pitchFamily="34" charset="-122"/>
+                          <a:cs typeface="Be Vietnam Pro" pitchFamily="34" charset="-120"/>
+                        </a:rPr>
+                        <a:t> trong</a:t>
+                      </a:r>
+                      <a:r>
+                        <a:rPr lang="en-US" sz="2250" dirty="0" spc="-11" kern="0">
+                          <a:solidFill>
+                            <a:srgbClr val="E4E1D8"/>
+                          </a:solidFill>
+                          <a:latin typeface="Be Vietnam Pro" pitchFamily="34" charset="0"/>
+                          <a:ea typeface="Be Vietnam Pro" pitchFamily="34" charset="-122"/>
+                          <a:cs typeface="Be Vietnam Pro" pitchFamily="34" charset="-120"/>
+                        </a:rPr>
+                        <a:t> CockroachDB</a:t>
+                      </a:r>
+                      <a:endParaRPr lang="en-US" sz="1200" dirty="0"/>
+                    </a:p>
+                  </a:txBody>
+                  <a:tcPr marL="76200" marR="76200" marT="76200" marB="76200">
+                    <a:lnL w="9525" cap="flat" cmpd="sng" algn="ctr">
+                      <a:solidFill>
+                        <a:srgbClr val="2D3140"/>
+                      </a:solidFill>
+                      <a:prstDash val="solid"/>
+                      <a:round/>
+                      <a:headEnd type="none" w="med" len="med"/>
+                      <a:tailEnd type="none" w="med" len="med"/>
+                    </a:lnL>
+                    <a:lnR w="9525" cap="flat" cmpd="sng" algn="ctr">
+                      <a:solidFill>
+                        <a:srgbClr val="2D3140"/>
+                      </a:solidFill>
+                      <a:prstDash val="solid"/>
+                      <a:round/>
+                      <a:headEnd type="none" w="med" len="med"/>
+                      <a:tailEnd type="none" w="med" len="med"/>
+                    </a:lnR>
+                    <a:lnT w="9525" cap="flat" cmpd="sng" algn="ctr">
+                      <a:solidFill>
+                        <a:srgbClr val="2D3140"/>
+                      </a:solidFill>
+                      <a:prstDash val="solid"/>
+                      <a:round/>
+                      <a:headEnd type="none" w="med" len="med"/>
+                      <a:tailEnd type="none" w="med" len="med"/>
+                    </a:lnT>
+                    <a:lnB w="0" cap="flat" cmpd="sng" algn="ctr">
+                      <a:noFill/>
+                    </a:lnB>
+                    <a:solidFill>
+                      <a:srgbClr val="1A1D25"/>
+                    </a:solidFill>
+                  </a:tcPr>
+                </a:tc>
+              </a:tr>
             </a:tbl>
           </a:graphicData>
         </a:graphic>
@@ -3864,7 +4331,7 @@
         </p:nvSpPr>
         <p:spPr>
           <a:xfrm>
-            <a:off x="914400" y="6915150"/>
+            <a:off x="914400" y="7677150"/>
             <a:ext cx="11430000" cy="428625"/>
           </a:xfrm>
           <a:prstGeom prst="rect">
@@ -3914,7 +4381,7 @@
         </p:nvSpPr>
         <p:spPr>
           <a:xfrm>
-            <a:off x="914400" y="7334250"/>
+            <a:off x="914400" y="8096250"/>
             <a:ext cx="16459200" cy="552450"/>
           </a:xfrm>
           <a:prstGeom prst="rect">
@@ -4030,7 +4497,7 @@
         </p:nvSpPr>
         <p:spPr>
           <a:xfrm>
-            <a:off x="914400" y="7867650"/>
+            <a:off x="914400" y="8629650"/>
             <a:ext cx="16459200" cy="390525"/>
           </a:xfrm>
           <a:prstGeom prst="rect">

</xml_diff>